<commit_message>
fix(ci): stabilize lock-sync platform and refresh evidence_board golden
Compile requirement locks for linux x86_64 so Windows hosts match ubuntu CI, and update drifted v2_evidence_board composition baselines.
</commit_message>
<xml_diff>
--- a/tests/golden/visual/composition/v2_evidence_board/deck.pptx
+++ b/tests/golden/visual/composition/v2_evidence_board/deck.pptx
@@ -910,7 +910,7 @@
         <p:spPr>
           <a:xfrm>
             <a:off x="640080" y="411480"/>
-            <a:ext cx="7863840" cy="400050"/>
+            <a:ext cx="7863840" cy="601218"/>
           </a:xfrm>
           <a:prstGeom prst="rect">
             <a:avLst/>
@@ -948,8 +948,8 @@
         </p:nvSpPr>
         <p:spPr>
           <a:xfrm>
-            <a:off x="640080" y="887730"/>
-            <a:ext cx="4804715" cy="2648712"/>
+            <a:off x="640080" y="1088898"/>
+            <a:ext cx="4804715" cy="2303160"/>
           </a:xfrm>
           <a:prstGeom prst="rect">
             <a:avLst/>
@@ -973,7 +973,7 @@
         </p:nvSpPr>
         <p:spPr>
           <a:xfrm>
-            <a:off x="777240" y="2029206"/>
+            <a:off x="777240" y="2057598"/>
             <a:ext cx="4530395" cy="365760"/>
           </a:xfrm>
           <a:prstGeom prst="rect">
@@ -1012,8 +1012,8 @@
         </p:nvSpPr>
         <p:spPr>
           <a:xfrm>
-            <a:off x="640080" y="3574542"/>
-            <a:ext cx="4804715" cy="361188"/>
+            <a:off x="640080" y="3430158"/>
+            <a:ext cx="4804715" cy="505572"/>
           </a:xfrm>
           <a:prstGeom prst="rect">
             <a:avLst/>
@@ -1051,8 +1051,8 @@
         </p:nvSpPr>
         <p:spPr>
           <a:xfrm>
-            <a:off x="5559095" y="887730"/>
-            <a:ext cx="2944825" cy="1257300"/>
+            <a:off x="5559095" y="1088898"/>
+            <a:ext cx="2944825" cy="1089096"/>
           </a:xfrm>
           <a:prstGeom prst="rect">
             <a:avLst/>
@@ -1076,7 +1076,7 @@
         </p:nvSpPr>
         <p:spPr>
           <a:xfrm>
-            <a:off x="5696255" y="1333500"/>
+            <a:off x="5696255" y="1450566"/>
             <a:ext cx="2670505" cy="365760"/>
           </a:xfrm>
           <a:prstGeom prst="rect">
@@ -1115,8 +1115,8 @@
         </p:nvSpPr>
         <p:spPr>
           <a:xfrm>
-            <a:off x="5559095" y="2183130"/>
-            <a:ext cx="2944825" cy="171450"/>
+            <a:off x="5559095" y="2216094"/>
+            <a:ext cx="2944825" cy="239070"/>
           </a:xfrm>
           <a:prstGeom prst="rect">
             <a:avLst/>
@@ -1154,8 +1154,8 @@
         </p:nvSpPr>
         <p:spPr>
           <a:xfrm>
-            <a:off x="5559095" y="2468880"/>
-            <a:ext cx="2944825" cy="1257300"/>
+            <a:off x="5559095" y="2569464"/>
+            <a:ext cx="2944825" cy="1089096"/>
           </a:xfrm>
           <a:prstGeom prst="rect">
             <a:avLst/>
@@ -1179,7 +1179,7 @@
         </p:nvSpPr>
         <p:spPr>
           <a:xfrm>
-            <a:off x="5696255" y="2914650"/>
+            <a:off x="5696255" y="2931132"/>
             <a:ext cx="2670505" cy="365760"/>
           </a:xfrm>
           <a:prstGeom prst="rect">
@@ -1218,8 +1218,8 @@
         </p:nvSpPr>
         <p:spPr>
           <a:xfrm>
-            <a:off x="5559095" y="3764280"/>
-            <a:ext cx="2944825" cy="171450"/>
+            <a:off x="5559095" y="3696660"/>
+            <a:ext cx="2944825" cy="239070"/>
           </a:xfrm>
           <a:prstGeom prst="rect">
             <a:avLst/>

</xml_diff>